<commit_message>
Add Solution Architect title to every author line
The README, PRD, Medium byline and slide deck named the author without
the Solution Architect title used in the other articles.
</commit_message>
<xml_diff>
--- a/docs/presentations/share-copilot-capacity.pptx
+++ b/docs/presentations/share-copilot-capacity.pptx
@@ -5288,7 +5288,7 @@
                 </a:solidFill>
                 <a:latin typeface="Arial"/>
               </a:rPr>
-              <a:t>Sr. Software Engineer / Solution Architect</a:t>
+              <a:t>Solution Architect</a:t>
             </a:r>
           </a:p>
           <a:p>
@@ -14323,7 +14323,7 @@
                 </a:solidFill>
                 <a:latin typeface="Arial"/>
               </a:rPr>
-              <a:t>Wallace Espindola</a:t>
+              <a:t>Wallace Espindola, Solution Architect</a:t>
             </a:r>
           </a:p>
           <a:p>

</xml_diff>